<commit_message>
updated perfmetdir and chartering
</commit_message>
<xml_diff>
--- a/ietf126-Vienna/slides/State of OPS Area-IPPM-BMWG-PERFMETRDIR.pptx
+++ b/ietf126-Vienna/slides/State of OPS Area-IPPM-BMWG-PERFMETRDIR.pptx
@@ -115,6 +115,14 @@
 </p:presentation>
 </file>
 
+<file path=ppt/revisionInfo.xml><?xml version="1.0" encoding="utf-8"?>
+<p1510:revInfo xmlns:a="http://schemas.openxmlformats.org/drawingml/2006/main" xmlns:r="http://schemas.openxmlformats.org/officeDocument/2006/relationships" xmlns:p1510="http://schemas.microsoft.com/office/powerpoint/2015/10/main">
+  <p1510:revLst>
+    <p1510:client id="{E6D4828F-2BF2-4797-BC2C-4C6CC2A4ED25}" v="5" dt="2026-07-09T05:48:16.561"/>
+  </p1510:revLst>
+</p1510:revInfo>
+</file>
+
 <file path=ppt/changesInfos/changesInfo1.xml><?xml version="1.0" encoding="utf-8"?>
 <pc:chgInfo xmlns:a="http://schemas.openxmlformats.org/drawingml/2006/main" xmlns:r="http://schemas.openxmlformats.org/officeDocument/2006/relationships" xmlns:ac="http://schemas.microsoft.com/office/drawing/2013/main/command" xmlns:pc="http://schemas.microsoft.com/office/powerpoint/2013/main/command">
   <pc:docChgLst>
@@ -165,6 +173,30 @@
       </pc:sldChg>
     </pc:docChg>
   </pc:docChgLst>
+  <pc:docChgLst>
+    <pc:chgData name="Graf Thomas, SCS-INI-NET-VNC-E2E" userId="487bc3e3-9ce7-4cdd-b7b4-8899ea88d289" providerId="ADAL" clId="{ADEEF08A-D719-4B50-A383-4105EDA2C206}"/>
+    <pc:docChg chg="undo custSel modSld">
+      <pc:chgData name="Graf Thomas, SCS-INI-NET-VNC-E2E" userId="487bc3e3-9ce7-4cdd-b7b4-8899ea88d289" providerId="ADAL" clId="{ADEEF08A-D719-4B50-A383-4105EDA2C206}" dt="2026-07-09T05:47:38.406" v="112" actId="6549"/>
+      <pc:docMkLst>
+        <pc:docMk/>
+      </pc:docMkLst>
+      <pc:sldChg chg="modSp mod">
+        <pc:chgData name="Graf Thomas, SCS-INI-NET-VNC-E2E" userId="487bc3e3-9ce7-4cdd-b7b4-8899ea88d289" providerId="ADAL" clId="{ADEEF08A-D719-4B50-A383-4105EDA2C206}" dt="2026-07-09T05:47:38.406" v="112" actId="6549"/>
+        <pc:sldMkLst>
+          <pc:docMk/>
+          <pc:sldMk cId="132822887" sldId="257"/>
+        </pc:sldMkLst>
+        <pc:spChg chg="mod">
+          <ac:chgData name="Graf Thomas, SCS-INI-NET-VNC-E2E" userId="487bc3e3-9ce7-4cdd-b7b4-8899ea88d289" providerId="ADAL" clId="{ADEEF08A-D719-4B50-A383-4105EDA2C206}" dt="2026-07-09T05:47:38.406" v="112" actId="6549"/>
+          <ac:spMkLst>
+            <pc:docMk/>
+            <pc:sldMk cId="132822887" sldId="257"/>
+            <ac:spMk id="3" creationId="{5082E14F-0499-0D67-CCEB-98C164D73BB5}"/>
+          </ac:spMkLst>
+        </pc:spChg>
+      </pc:sldChg>
+    </pc:docChg>
+  </pc:docChgLst>
 </pc:chgInfo>
 </file>
 
@@ -250,7 +282,7 @@
           <a:p>
             <a:fld id="{993813BE-9644-4EB0-A6C4-0B9517916EF9}" type="datetimeFigureOut">
               <a:rPr lang="fr-FR" smtClean="0"/>
-              <a:t>08/07/2026</a:t>
+              <a:t>09/07/2026</a:t>
             </a:fld>
             <a:endParaRPr lang="fr-FR" dirty="0"/>
           </a:p>
@@ -748,7 +780,7 @@
           <a:p>
             <a:fld id="{AF3A2D09-215D-4610-87DE-176F93FAFFFB}" type="datetime1">
               <a:rPr lang="fr-FR" smtClean="0"/>
-              <a:t>08/07/2026</a:t>
+              <a:t>09/07/2026</a:t>
             </a:fld>
             <a:endParaRPr lang="fr-FR" dirty="0"/>
           </a:p>
@@ -950,7 +982,7 @@
           <a:p>
             <a:fld id="{7F2B3DBA-070E-4070-BF49-61ED05E982A8}" type="datetime1">
               <a:rPr lang="fr-FR" smtClean="0"/>
-              <a:t>08/07/2026</a:t>
+              <a:t>09/07/2026</a:t>
             </a:fld>
             <a:endParaRPr lang="fr-FR" dirty="0"/>
           </a:p>
@@ -1162,7 +1194,7 @@
           <a:p>
             <a:fld id="{1861926C-C024-4DC6-8C34-EC76F14394CD}" type="datetime1">
               <a:rPr lang="fr-FR" smtClean="0"/>
-              <a:t>08/07/2026</a:t>
+              <a:t>09/07/2026</a:t>
             </a:fld>
             <a:endParaRPr lang="fr-FR" dirty="0"/>
           </a:p>
@@ -1364,7 +1396,7 @@
           <a:p>
             <a:fld id="{1FEACCCC-DFCC-4756-9119-F1F4182DEE79}" type="datetime1">
               <a:rPr lang="fr-FR" smtClean="0"/>
-              <a:t>08/07/2026</a:t>
+              <a:t>09/07/2026</a:t>
             </a:fld>
             <a:endParaRPr lang="fr-FR" dirty="0"/>
           </a:p>
@@ -1643,7 +1675,7 @@
           <a:p>
             <a:fld id="{F166DA53-6888-4012-9540-B1A2D306F057}" type="datetime1">
               <a:rPr lang="fr-FR" smtClean="0"/>
-              <a:t>08/07/2026</a:t>
+              <a:t>09/07/2026</a:t>
             </a:fld>
             <a:endParaRPr lang="fr-FR" dirty="0"/>
           </a:p>
@@ -1912,7 +1944,7 @@
           <a:p>
             <a:fld id="{B2712EA3-61AF-4B68-96B7-FD0EF5B6D1CF}" type="datetime1">
               <a:rPr lang="fr-FR" smtClean="0"/>
-              <a:t>08/07/2026</a:t>
+              <a:t>09/07/2026</a:t>
             </a:fld>
             <a:endParaRPr lang="fr-FR" dirty="0"/>
           </a:p>
@@ -2328,7 +2360,7 @@
           <a:p>
             <a:fld id="{397F3E34-6190-4D3B-AA13-9C745685F55B}" type="datetime1">
               <a:rPr lang="fr-FR" smtClean="0"/>
-              <a:t>08/07/2026</a:t>
+              <a:t>09/07/2026</a:t>
             </a:fld>
             <a:endParaRPr lang="fr-FR" dirty="0"/>
           </a:p>
@@ -2473,7 +2505,7 @@
           <a:p>
             <a:fld id="{16A0672A-08CA-4958-B194-97B82EC017A1}" type="datetime1">
               <a:rPr lang="fr-FR" smtClean="0"/>
-              <a:t>08/07/2026</a:t>
+              <a:t>09/07/2026</a:t>
             </a:fld>
             <a:endParaRPr lang="fr-FR" dirty="0"/>
           </a:p>
@@ -2590,7 +2622,7 @@
           <a:p>
             <a:fld id="{716B3D01-0A26-4955-A3B9-82886643D6B4}" type="datetime1">
               <a:rPr lang="fr-FR" smtClean="0"/>
-              <a:t>08/07/2026</a:t>
+              <a:t>09/07/2026</a:t>
             </a:fld>
             <a:endParaRPr lang="fr-FR" dirty="0"/>
           </a:p>
@@ -2905,7 +2937,7 @@
           <a:p>
             <a:fld id="{13A4B2D0-68E8-43E1-BC8F-2FA077EAE1FE}" type="datetime1">
               <a:rPr lang="fr-FR" smtClean="0"/>
-              <a:t>08/07/2026</a:t>
+              <a:t>09/07/2026</a:t>
             </a:fld>
             <a:endParaRPr lang="fr-FR" dirty="0"/>
           </a:p>
@@ -3197,7 +3229,7 @@
           <a:p>
             <a:fld id="{631352CE-85DA-4448-A952-A5096EB6C4CB}" type="datetime1">
               <a:rPr lang="fr-FR" smtClean="0"/>
-              <a:t>08/07/2026</a:t>
+              <a:t>09/07/2026</a:t>
             </a:fld>
             <a:endParaRPr lang="fr-FR" dirty="0"/>
           </a:p>
@@ -3442,7 +3474,7 @@
           <a:p>
             <a:fld id="{CBB112E7-EB8B-4390-BCC3-B52E854F5AF2}" type="datetime1">
               <a:rPr lang="fr-FR" smtClean="0"/>
-              <a:t>08/07/2026</a:t>
+              <a:t>09/07/2026</a:t>
             </a:fld>
             <a:endParaRPr lang="fr-FR" dirty="0"/>
           </a:p>
@@ -3923,7 +3955,7 @@
         </p:spPr>
         <p:txBody>
           <a:bodyPr numCol="2">
-            <a:normAutofit fontScale="85000" lnSpcReduction="20000"/>
+            <a:normAutofit fontScale="77500" lnSpcReduction="20000"/>
           </a:bodyPr>
           <a:lstStyle/>
           <a:p>
@@ -3969,233 +4001,6 @@
             <a:r>
               <a:rPr lang="en-US" dirty="0"/>
               <a:t>Benchmarking Methodology for technologies developed in other SDOs or IETF WGs: e.g. Segment Routing, GREEN, CATS,…</a:t>
-            </a:r>
-          </a:p>
-          <a:p>
-            <a:pPr marL="0" indent="0">
-              <a:buNone/>
-            </a:pPr>
-            <a:endParaRPr lang="en-US" b="1" dirty="0"/>
-          </a:p>
-          <a:p>
-            <a:r>
-              <a:rPr lang="en-US" b="1" dirty="0"/>
-              <a:t>Main Achievements Since IETF#125</a:t>
-            </a:r>
-          </a:p>
-          <a:p>
-            <a:pPr lvl="1"/>
-            <a:r>
-              <a:rPr lang="en-US" sz="2200" u="sng" dirty="0"/>
-              <a:t>draft-</a:t>
-            </a:r>
-            <a:r>
-              <a:rPr lang="en-US" sz="2200" u="sng" dirty="0" err="1"/>
-              <a:t>ietf</a:t>
-            </a:r>
-            <a:r>
-              <a:rPr lang="en-US" sz="2200" u="sng" dirty="0"/>
-              <a:t>-ippm-</a:t>
-            </a:r>
-            <a:r>
-              <a:rPr lang="en-US" sz="2200" u="sng" dirty="0" err="1"/>
-              <a:t>qoo</a:t>
-            </a:r>
-            <a:r>
-              <a:rPr lang="en-US" sz="2200" dirty="0"/>
-              <a:t>, </a:t>
-            </a:r>
-            <a:r>
-              <a:rPr lang="en-US" sz="2200" u="sng" dirty="0"/>
-              <a:t>draft-</a:t>
-            </a:r>
-            <a:r>
-              <a:rPr lang="en-US" sz="2200" u="sng" dirty="0" err="1"/>
-              <a:t>ietf</a:t>
-            </a:r>
-            <a:r>
-              <a:rPr lang="en-US" sz="2200" u="sng" dirty="0"/>
-              <a:t>-ippm-</a:t>
-            </a:r>
-            <a:r>
-              <a:rPr lang="en-US" sz="2200" u="sng" dirty="0" err="1"/>
-              <a:t>ioam</a:t>
-            </a:r>
-            <a:r>
-              <a:rPr lang="en-US" sz="2200" u="sng" dirty="0"/>
-              <a:t>-data-integrity</a:t>
-            </a:r>
-            <a:r>
-              <a:rPr lang="en-US" sz="2200" dirty="0"/>
-              <a:t> and </a:t>
-            </a:r>
-            <a:r>
-              <a:rPr lang="en-US" sz="2200" u="sng" dirty="0"/>
-              <a:t>draft-</a:t>
-            </a:r>
-            <a:r>
-              <a:rPr lang="en-US" sz="2200" u="sng" dirty="0" err="1"/>
-              <a:t>ietf</a:t>
-            </a:r>
-            <a:r>
-              <a:rPr lang="en-US" sz="2200" u="sng" dirty="0"/>
-              <a:t>-ippm-</a:t>
-            </a:r>
-            <a:r>
-              <a:rPr lang="en-US" sz="2200" u="sng" dirty="0" err="1"/>
-              <a:t>ioam</a:t>
-            </a:r>
-            <a:r>
-              <a:rPr lang="en-US" sz="2200" u="sng" dirty="0"/>
-              <a:t>-integrity-yang</a:t>
-            </a:r>
-            <a:r>
-              <a:rPr lang="en-US" sz="2200" dirty="0"/>
-              <a:t> in RFC Ed Queue</a:t>
-            </a:r>
-          </a:p>
-          <a:p>
-            <a:pPr lvl="1"/>
-            <a:r>
-              <a:rPr lang="en-US" sz="2200" u="sng" dirty="0"/>
-              <a:t>draft-</a:t>
-            </a:r>
-            <a:r>
-              <a:rPr lang="en-US" sz="2200" u="sng" dirty="0" err="1"/>
-              <a:t>ietf</a:t>
-            </a:r>
-            <a:r>
-              <a:rPr lang="en-US" sz="2200" u="sng" dirty="0"/>
-              <a:t>-bmwg-network-tester-</a:t>
-            </a:r>
-            <a:r>
-              <a:rPr lang="en-US" sz="2200" u="sng" dirty="0" err="1"/>
-              <a:t>cfg</a:t>
-            </a:r>
-            <a:r>
-              <a:rPr lang="en-US" sz="2200" dirty="0"/>
-              <a:t> in RFC Ed Queue </a:t>
-            </a:r>
-          </a:p>
-          <a:p>
-            <a:pPr lvl="1"/>
-            <a:r>
-              <a:rPr lang="en-US" sz="2200" u="sng" dirty="0"/>
-              <a:t>draft-</a:t>
-            </a:r>
-            <a:r>
-              <a:rPr lang="en-US" sz="2200" u="sng" dirty="0" err="1"/>
-              <a:t>ietf</a:t>
-            </a:r>
-            <a:r>
-              <a:rPr lang="en-US" sz="2200" u="sng" dirty="0"/>
-              <a:t>-bmwg-</a:t>
-            </a:r>
-            <a:r>
-              <a:rPr lang="en-US" sz="2200" u="sng" dirty="0" err="1"/>
-              <a:t>sr</a:t>
-            </a:r>
-            <a:r>
-              <a:rPr lang="en-US" sz="2200" u="sng" dirty="0"/>
-              <a:t>-bench-meth</a:t>
-            </a:r>
-            <a:r>
-              <a:rPr lang="en-US" sz="2200" dirty="0"/>
-              <a:t> in AD Review</a:t>
-            </a:r>
-          </a:p>
-          <a:p>
-            <a:pPr lvl="1"/>
-            <a:r>
-              <a:rPr lang="en-US" sz="2200" u="sng" dirty="0"/>
-              <a:t>draft-</a:t>
-            </a:r>
-            <a:r>
-              <a:rPr lang="en-US" sz="2200" u="sng" dirty="0" err="1"/>
-              <a:t>ietf</a:t>
-            </a:r>
-            <a:r>
-              <a:rPr lang="en-US" sz="2200" u="sng" dirty="0"/>
-              <a:t>-ippm-alt-mark-deployment</a:t>
-            </a:r>
-            <a:r>
-              <a:rPr lang="en-US" sz="2200" dirty="0"/>
-              <a:t> and</a:t>
-            </a:r>
-            <a:r>
-              <a:rPr lang="en-US" sz="2200" u="sng" dirty="0"/>
-              <a:t> draft-</a:t>
-            </a:r>
-            <a:r>
-              <a:rPr lang="en-US" sz="2200" u="sng" dirty="0" err="1"/>
-              <a:t>ietf</a:t>
-            </a:r>
-            <a:r>
-              <a:rPr lang="en-US" sz="2200" u="sng" dirty="0"/>
-              <a:t>-ippm-alt-mark-yang</a:t>
-            </a:r>
-            <a:r>
-              <a:rPr lang="en-US" sz="2200" dirty="0"/>
-              <a:t> concluded the WGLC</a:t>
-            </a:r>
-          </a:p>
-          <a:p>
-            <a:pPr lvl="1"/>
-            <a:r>
-              <a:rPr lang="en-US" sz="2200" u="sng" dirty="0"/>
-              <a:t>draft-</a:t>
-            </a:r>
-            <a:r>
-              <a:rPr lang="en-US" sz="2200" u="sng" dirty="0" err="1"/>
-              <a:t>ietf</a:t>
-            </a:r>
-            <a:r>
-              <a:rPr lang="en-US" sz="2200" u="sng" dirty="0"/>
-              <a:t>-ippm-stamp-</a:t>
-            </a:r>
-            <a:r>
-              <a:rPr lang="en-US" sz="2200" u="sng" dirty="0" err="1"/>
-              <a:t>ext</a:t>
-            </a:r>
-            <a:r>
-              <a:rPr lang="en-US" sz="2200" u="sng" dirty="0"/>
-              <a:t>-</a:t>
-            </a:r>
-            <a:r>
-              <a:rPr lang="en-US" sz="2200" u="sng" dirty="0" err="1"/>
-              <a:t>hdr</a:t>
-            </a:r>
-            <a:r>
-              <a:rPr lang="en-US" sz="2200" dirty="0"/>
-              <a:t> in WGLC</a:t>
-            </a:r>
-          </a:p>
-          <a:p>
-            <a:pPr lvl="1"/>
-            <a:r>
-              <a:rPr lang="en-US" sz="2200" dirty="0"/>
-              <a:t>Joint IPPM/BMWG sessions working well</a:t>
-            </a:r>
-          </a:p>
-          <a:p>
-            <a:r>
-              <a:rPr lang="en-US" b="1" dirty="0"/>
-              <a:t>Admin Changes Since IETF#125</a:t>
-            </a:r>
-          </a:p>
-          <a:p>
-            <a:pPr lvl="1"/>
-            <a:r>
-              <a:rPr lang="en-US" dirty="0"/>
-              <a:t>Charter Update: joint charter proposal</a:t>
-            </a:r>
-            <a:endParaRPr lang="en-US" b="1" dirty="0"/>
-          </a:p>
-          <a:p>
-            <a:pPr lvl="1"/>
-            <a:r>
-              <a:rPr lang="en-US" dirty="0"/>
-              <a:t>Leadership Update: No</a:t>
             </a:r>
           </a:p>
           <a:p>
@@ -4205,23 +4010,267 @@
               </a:spcBef>
             </a:pPr>
             <a:r>
-              <a:rPr lang="en-US" sz="2800" b="1" noProof="0" dirty="0" err="1"/>
+              <a:rPr lang="en-US" b="1" dirty="0" err="1"/>
               <a:t>Perfmetrdir</a:t>
             </a:r>
             <a:r>
-              <a:rPr lang="en-US" sz="2800" b="1" noProof="0" dirty="0"/>
+              <a:rPr lang="en-US" b="1" dirty="0"/>
               <a:t> Updates Since IETF#125</a:t>
             </a:r>
           </a:p>
           <a:p>
             <a:pPr lvl="1"/>
             <a:r>
-              <a:rPr lang="en-US" sz="2500" noProof="0" dirty="0"/>
-              <a:t>none</a:t>
-            </a:r>
-          </a:p>
-          <a:p>
-            <a:endParaRPr lang="en-US" dirty="0"/>
+              <a:rPr lang="en-US" dirty="0"/>
+              <a:t>3 review requests related to STAMP and IOAM (draft-ietf-mpls-mna-ioam-06, draft-</a:t>
+            </a:r>
+            <a:r>
+              <a:rPr lang="en-US" dirty="0" err="1"/>
+              <a:t>ietf</a:t>
+            </a:r>
+            <a:r>
+              <a:rPr lang="en-US" dirty="0"/>
+              <a:t>-</a:t>
+            </a:r>
+            <a:r>
+              <a:rPr lang="en-US" dirty="0" err="1"/>
+              <a:t>mpls</a:t>
+            </a:r>
+            <a:r>
+              <a:rPr lang="en-US" dirty="0"/>
+              <a:t>-stamp-pw, draft-ietf-ippm-stamp-ext-hdr )</a:t>
+            </a:r>
+          </a:p>
+          <a:p>
+            <a:r>
+              <a:rPr lang="en-US" b="1" dirty="0"/>
+              <a:t>Main Achievements Since IETF#125</a:t>
+            </a:r>
+          </a:p>
+          <a:p>
+            <a:pPr lvl="1"/>
+            <a:r>
+              <a:rPr lang="en-US" sz="2500" u="sng" dirty="0"/>
+              <a:t>draft-</a:t>
+            </a:r>
+            <a:r>
+              <a:rPr lang="en-US" sz="2500" u="sng" dirty="0" err="1"/>
+              <a:t>ietf</a:t>
+            </a:r>
+            <a:r>
+              <a:rPr lang="en-US" sz="2500" u="sng" dirty="0"/>
+              <a:t>-ippm-</a:t>
+            </a:r>
+            <a:r>
+              <a:rPr lang="en-US" sz="2500" u="sng" dirty="0" err="1"/>
+              <a:t>qoo</a:t>
+            </a:r>
+            <a:r>
+              <a:rPr lang="en-US" sz="2500" dirty="0"/>
+              <a:t>, </a:t>
+            </a:r>
+            <a:r>
+              <a:rPr lang="en-US" sz="2500" u="sng" dirty="0"/>
+              <a:t>draft-</a:t>
+            </a:r>
+            <a:r>
+              <a:rPr lang="en-US" sz="2500" u="sng" dirty="0" err="1"/>
+              <a:t>ietf</a:t>
+            </a:r>
+            <a:r>
+              <a:rPr lang="en-US" sz="2500" u="sng" dirty="0"/>
+              <a:t>-ippm-</a:t>
+            </a:r>
+            <a:r>
+              <a:rPr lang="en-US" sz="2500" u="sng" dirty="0" err="1"/>
+              <a:t>ioam</a:t>
+            </a:r>
+            <a:r>
+              <a:rPr lang="en-US" sz="2500" u="sng" dirty="0"/>
+              <a:t>-data-integrity</a:t>
+            </a:r>
+            <a:r>
+              <a:rPr lang="en-US" sz="2500" dirty="0"/>
+              <a:t> and </a:t>
+            </a:r>
+            <a:r>
+              <a:rPr lang="en-US" sz="2500" u="sng" dirty="0"/>
+              <a:t>draft-</a:t>
+            </a:r>
+            <a:r>
+              <a:rPr lang="en-US" sz="2500" u="sng" dirty="0" err="1"/>
+              <a:t>ietf</a:t>
+            </a:r>
+            <a:r>
+              <a:rPr lang="en-US" sz="2500" u="sng" dirty="0"/>
+              <a:t>-ippm-</a:t>
+            </a:r>
+            <a:r>
+              <a:rPr lang="en-US" sz="2500" u="sng" dirty="0" err="1"/>
+              <a:t>ioam</a:t>
+            </a:r>
+            <a:r>
+              <a:rPr lang="en-US" sz="2500" u="sng" dirty="0"/>
+              <a:t>-integrity-yang</a:t>
+            </a:r>
+            <a:r>
+              <a:rPr lang="en-US" sz="2500" dirty="0"/>
+              <a:t> in RFC Ed Queue</a:t>
+            </a:r>
+          </a:p>
+          <a:p>
+            <a:pPr lvl="1"/>
+            <a:r>
+              <a:rPr lang="en-US" sz="2500" u="sng" dirty="0"/>
+              <a:t>draft-</a:t>
+            </a:r>
+            <a:r>
+              <a:rPr lang="en-US" sz="2500" u="sng" dirty="0" err="1"/>
+              <a:t>ietf</a:t>
+            </a:r>
+            <a:r>
+              <a:rPr lang="en-US" sz="2500" u="sng" dirty="0"/>
+              <a:t>-bmwg-network-tester-</a:t>
+            </a:r>
+            <a:r>
+              <a:rPr lang="en-US" sz="2500" u="sng" dirty="0" err="1"/>
+              <a:t>cfg</a:t>
+            </a:r>
+            <a:r>
+              <a:rPr lang="en-US" sz="2500" dirty="0"/>
+              <a:t> in RFC Ed Queue </a:t>
+            </a:r>
+          </a:p>
+          <a:p>
+            <a:pPr lvl="1"/>
+            <a:r>
+              <a:rPr lang="en-US" sz="2500" u="sng" dirty="0"/>
+              <a:t>draft-</a:t>
+            </a:r>
+            <a:r>
+              <a:rPr lang="en-US" sz="2500" u="sng" dirty="0" err="1"/>
+              <a:t>ietf</a:t>
+            </a:r>
+            <a:r>
+              <a:rPr lang="en-US" sz="2500" u="sng" dirty="0"/>
+              <a:t>-bmwg-</a:t>
+            </a:r>
+            <a:r>
+              <a:rPr lang="en-US" sz="2500" u="sng" dirty="0" err="1"/>
+              <a:t>sr</a:t>
+            </a:r>
+            <a:r>
+              <a:rPr lang="en-US" sz="2500" u="sng" dirty="0"/>
+              <a:t>-bench-meth</a:t>
+            </a:r>
+            <a:r>
+              <a:rPr lang="en-US" sz="2500" dirty="0"/>
+              <a:t> in AD Review</a:t>
+            </a:r>
+          </a:p>
+          <a:p>
+            <a:pPr lvl="1"/>
+            <a:r>
+              <a:rPr lang="en-US" sz="2500" u="sng" dirty="0"/>
+              <a:t>draft-</a:t>
+            </a:r>
+            <a:r>
+              <a:rPr lang="en-US" sz="2500" u="sng" dirty="0" err="1"/>
+              <a:t>ietf</a:t>
+            </a:r>
+            <a:r>
+              <a:rPr lang="en-US" sz="2500" u="sng" dirty="0"/>
+              <a:t>-ippm-alt-mark-deployment</a:t>
+            </a:r>
+            <a:r>
+              <a:rPr lang="en-US" sz="2500" dirty="0"/>
+              <a:t> and</a:t>
+            </a:r>
+            <a:r>
+              <a:rPr lang="en-US" sz="2500" u="sng" dirty="0"/>
+              <a:t> draft-</a:t>
+            </a:r>
+            <a:r>
+              <a:rPr lang="en-US" sz="2500" u="sng" dirty="0" err="1"/>
+              <a:t>ietf</a:t>
+            </a:r>
+            <a:r>
+              <a:rPr lang="en-US" sz="2500" u="sng" dirty="0"/>
+              <a:t>-ippm-alt-mark-yang</a:t>
+            </a:r>
+            <a:r>
+              <a:rPr lang="en-US" sz="2500" dirty="0"/>
+              <a:t> concluded the WGLC</a:t>
+            </a:r>
+          </a:p>
+          <a:p>
+            <a:pPr lvl="1"/>
+            <a:r>
+              <a:rPr lang="en-US" sz="2500" u="sng" dirty="0"/>
+              <a:t>draft-</a:t>
+            </a:r>
+            <a:r>
+              <a:rPr lang="en-US" sz="2500" u="sng" dirty="0" err="1"/>
+              <a:t>ietf</a:t>
+            </a:r>
+            <a:r>
+              <a:rPr lang="en-US" sz="2500" u="sng" dirty="0"/>
+              <a:t>-ippm-stamp-</a:t>
+            </a:r>
+            <a:r>
+              <a:rPr lang="en-US" sz="2500" u="sng" dirty="0" err="1"/>
+              <a:t>ext</a:t>
+            </a:r>
+            <a:r>
+              <a:rPr lang="en-US" sz="2500" u="sng" dirty="0"/>
+              <a:t>-</a:t>
+            </a:r>
+            <a:r>
+              <a:rPr lang="en-US" sz="2500" u="sng" dirty="0" err="1"/>
+              <a:t>hdr</a:t>
+            </a:r>
+            <a:r>
+              <a:rPr lang="en-US" sz="2500" dirty="0"/>
+              <a:t> in WGLC</a:t>
+            </a:r>
+          </a:p>
+          <a:p>
+            <a:pPr lvl="1"/>
+            <a:r>
+              <a:rPr lang="en-US" sz="2500" dirty="0"/>
+              <a:t>Joint IPPM/BMWG sessions working well</a:t>
+            </a:r>
+          </a:p>
+          <a:p>
+            <a:r>
+              <a:rPr lang="en-US" b="1" dirty="0"/>
+              <a:t>Admin Changes Since IETF#125</a:t>
+            </a:r>
+          </a:p>
+          <a:p>
+            <a:pPr lvl="1"/>
+            <a:r>
+              <a:rPr lang="en-US" dirty="0"/>
+              <a:t>Charter Update: Finalizing </a:t>
+            </a:r>
+            <a:r>
+              <a:rPr lang="en-US" dirty="0">
+                <a:hlinkClick r:id="rId3"/>
+              </a:rPr>
+              <a:t>joint charter proposal</a:t>
+            </a:r>
+            <a:r>
+              <a:rPr lang="en-US" dirty="0"/>
+              <a:t>. Reaching consensus.</a:t>
+            </a:r>
+            <a:endParaRPr lang="en-US" b="1" dirty="0"/>
+          </a:p>
+          <a:p>
+            <a:pPr lvl="1"/>
+            <a:r>
+              <a:rPr lang="en-US" dirty="0"/>
+              <a:t>Leadership Update: No</a:t>
+            </a:r>
           </a:p>
         </p:txBody>
       </p:sp>
@@ -4929,5 +4978,6 @@
 <file path=docMetadata/LabelInfo.xml><?xml version="1.0" encoding="utf-8"?>
 <clbl:labelList xmlns:clbl="http://schemas.microsoft.com/office/2020/mipLabelMetadata">
   <clbl:label id="{07222825-62ea-40f3-96b5-5375c07996e2}" enabled="1" method="Privileged" siteId="{90c7a20a-f34b-40bf-bc48-b9253b6f5d20}" removed="0"/>
+  <clbl:label id="{2e1fccfb-80ca-4fe1-a574-1516544edb53}" enabled="1" method="Standard" siteId="{364e5b87-c1c7-420d-9bee-c35d19b557a1}" removed="0"/>
 </clbl:labelList>
 </file>
</xml_diff>